<commit_message>
feat: cinematic trailer — 2-minute Remotion video with 14 scenes
Two-act trailer built with Remotion (programmatic video from React):
- Act 1: Pure noir cinema — city, role reveals, voting, stakes, glitch transition
- Act 2: Origin story — "8 nights, day job, AI doesn't sleep", plan scroll,
  Claude Code split-screen building, 29-agent QA audit, stats with $2 mic drop

Generated assets: 9 narrator voiceovers (Gemini TTS) + 4 images (Imagen 4)
Components: TerminalSimulation, MultiTerminal, DocumentScroll, KenBurns,
CardReveal, StatsCounter, SplitScreen, FilmGrain, and more

Also: "8 days" → "8 nights" across all docs/code/narrator, PPT regenerated,
temp files cleaned up, README trailer section added, evidence package updated

Co-Authored-By: Claude Opus 4.6 (1M context) <noreply@anthropic.com>
</commit_message>
<xml_diff>
--- a/projects/undercover-mob-boss/docs/UMB-Executive-Summary.pptx
+++ b/projects/undercover-mob-boss/docs/UMB-Executive-Summary.pptx
@@ -1577,7 +1577,7 @@
                 <a:ea typeface="Georgia" pitchFamily="34" charset="-122"/>
                 <a:cs typeface="Georgia" pitchFamily="34" charset="-120"/>
               </a:rPr>
-              <a:t>Concept to Production in 8 Days</a:t>
+              <a:t>Concept to Production in 8 Nights</a:t>
             </a:r>
             <a:endParaRPr lang="en-US" sz="2200" dirty="0"/>
           </a:p>
@@ -2913,7 +2913,7 @@
                 <a:ea typeface="Georgia" pitchFamily="34" charset="-122"/>
                 <a:cs typeface="Georgia" pitchFamily="34" charset="-120"/>
               </a:rPr>
-              <a:t>Day 1</a:t>
+              <a:t>Night 1</a:t>
             </a:r>
             <a:endParaRPr lang="en-US" sz="1300" dirty="0"/>
           </a:p>
@@ -3011,7 +3011,7 @@
                 <a:ea typeface="Georgia" pitchFamily="34" charset="-122"/>
                 <a:cs typeface="Georgia" pitchFamily="34" charset="-120"/>
               </a:rPr>
-              <a:t>Day 2</a:t>
+              <a:t>Night 2</a:t>
             </a:r>
             <a:endParaRPr lang="en-US" sz="1300" dirty="0"/>
           </a:p>
@@ -3109,7 +3109,7 @@
                 <a:ea typeface="Georgia" pitchFamily="34" charset="-122"/>
                 <a:cs typeface="Georgia" pitchFamily="34" charset="-120"/>
               </a:rPr>
-              <a:t>Day 3</a:t>
+              <a:t>Night 3</a:t>
             </a:r>
             <a:endParaRPr lang="en-US" sz="1300" dirty="0"/>
           </a:p>
@@ -3207,7 +3207,7 @@
                 <a:ea typeface="Georgia" pitchFamily="34" charset="-122"/>
                 <a:cs typeface="Georgia" pitchFamily="34" charset="-120"/>
               </a:rPr>
-              <a:t>Days 4–5</a:t>
+              <a:t>Nights 4–5</a:t>
             </a:r>
             <a:endParaRPr lang="en-US" sz="1300" dirty="0"/>
           </a:p>
@@ -3305,7 +3305,7 @@
                 <a:ea typeface="Georgia" pitchFamily="34" charset="-122"/>
                 <a:cs typeface="Georgia" pitchFamily="34" charset="-120"/>
               </a:rPr>
-              <a:t>Day 6</a:t>
+              <a:t>Night 6</a:t>
             </a:r>
             <a:endParaRPr lang="en-US" sz="1300" dirty="0"/>
           </a:p>
@@ -3403,7 +3403,7 @@
                 <a:ea typeface="Georgia" pitchFamily="34" charset="-122"/>
                 <a:cs typeface="Georgia" pitchFamily="34" charset="-120"/>
               </a:rPr>
-              <a:t>Days 7–8</a:t>
+              <a:t>Nights 7–8</a:t>
             </a:r>
             <a:endParaRPr lang="en-US" sz="1300" dirty="0"/>
           </a:p>

</xml_diff>

<commit_message>
docs: change "architectural defects" to "functional defects" throughout
Updated evidence package, PPT generator, narrator script, trailer stats.
Regenerated trailer-build-stats.wav and UMB-Executive-Summary.pptx.

Co-Authored-By: Claude Opus 4.6 (1M context) <noreply@anthropic.com>
</commit_message>
<xml_diff>
--- a/projects/undercover-mob-boss/docs/UMB-Executive-Summary.pptx
+++ b/projects/undercover-mob-boss/docs/UMB-Executive-Summary.pptx
@@ -4163,7 +4163,7 @@
                 <a:ea typeface="Calibri" pitchFamily="34" charset="-122"/>
                 <a:cs typeface="Calibri" pitchFamily="34" charset="-120"/>
               </a:rPr>
-              <a:t>Architectural Defects</a:t>
+              <a:t>Functional Defects</a:t>
             </a:r>
             <a:endParaRPr lang="en-US" sz="1400" dirty="0"/>
           </a:p>
@@ -4202,7 +4202,7 @@
                 <a:ea typeface="Calibri" pitchFamily="34" charset="-122"/>
                 <a:cs typeface="Calibri" pitchFamily="34" charset="-120"/>
               </a:rPr>
-              <a:t>Engine correct from day one</a:t>
+              <a:t>Engine correct from night one</a:t>
             </a:r>
             <a:endParaRPr lang="en-US" sz="1100" dirty="0"/>
           </a:p>
@@ -6261,7 +6261,7 @@
                 <a:ea typeface="Georgia" pitchFamily="34" charset="-122"/>
                 <a:cs typeface="Georgia" pitchFamily="34" charset="-120"/>
               </a:rPr>
-              <a:t>Zero architectural defects. Zero game logic defects. The spec was right — so the code was right.</a:t>
+              <a:t>Zero functional defects. The spec was right — so the code was right.</a:t>
             </a:r>
             <a:endParaRPr lang="en-US" sz="1400" dirty="0"/>
           </a:p>

</xml_diff>